<commit_message>
Add prompts to deck speaker notes + one-page facilitator cheat-sheet
Co-Authored-By: Claude Opus 4.8 (1M context) <noreply@anthropic.com>
</commit_message>
<xml_diff>
--- a/dms-workshop/AI-Powered-Product-Development_DMS.pptx
+++ b/dms-workshop/AI-Powered-Product-Development_DMS.pptx
@@ -18,19 +18,19 @@
     <p:sldId id="266" r:id="rId17"/>
     <p:sldId id="267" r:id="rId18"/>
     <p:sldId id="268" r:id="rId19"/>
-    <p:sldId id="269" r:id="rId20"/>
-    <p:sldId id="270" r:id="rId21"/>
-    <p:sldId id="271" r:id="rId22"/>
-    <p:sldId id="272" r:id="rId23"/>
-    <p:sldId id="273" r:id="rId24"/>
-    <p:sldId id="274" r:id="rId25"/>
-    <p:sldId id="275" r:id="rId26"/>
-    <p:sldId id="276" r:id="rId27"/>
-    <p:sldId id="277" r:id="rId28"/>
-    <p:sldId id="278" r:id="rId29"/>
-    <p:sldId id="279" r:id="rId30"/>
-    <p:sldId id="280" r:id="rId31"/>
-    <p:sldId id="281" r:id="rId32"/>
+    <p:sldId id="269" r:id="rId21"/>
+    <p:sldId id="270" r:id="rId22"/>
+    <p:sldId id="271" r:id="rId23"/>
+    <p:sldId id="272" r:id="rId24"/>
+    <p:sldId id="273" r:id="rId25"/>
+    <p:sldId id="274" r:id="rId26"/>
+    <p:sldId id="275" r:id="rId27"/>
+    <p:sldId id="276" r:id="rId28"/>
+    <p:sldId id="277" r:id="rId29"/>
+    <p:sldId id="278" r:id="rId30"/>
+    <p:sldId id="279" r:id="rId31"/>
+    <p:sldId id="280" r:id="rId32"/>
+    <p:sldId id="281" r:id="rId33"/>
   </p:sldIdLst>
   <p:sldSz cx="12191695" cy="6858000" type="screen4x3"/>
   <p:notesSz cx="6858000" cy="9144000"/>
@@ -130,6 +130,1093 @@
     </a:lvl9pPr>
   </p:defaultTextStyle>
 </p:presentation>
+</file>
+
+<file path=ppt/notesMasters/notesMaster1.xml><?xml version="1.0" encoding="utf-8"?>
+<p:notesMaster xmlns:a="http://schemas.openxmlformats.org/drawingml/2006/main" xmlns:p="http://schemas.openxmlformats.org/presentationml/2006/main" xmlns:r="http://schemas.openxmlformats.org/officeDocument/2006/relationships">
+  <p:cSld>
+    <p:bg>
+      <p:bgRef idx="1001">
+        <a:schemeClr val="bg1"/>
+      </p:bgRef>
+    </p:bg>
+    <p:spTree>
+      <p:nvGrpSpPr>
+        <p:cNvPr id="1" name=""/>
+        <p:cNvGrpSpPr/>
+        <p:nvPr/>
+      </p:nvGrpSpPr>
+      <p:grpSpPr>
+        <a:xfrm>
+          <a:off x="0" y="0"/>
+          <a:ext cx="0" cy="0"/>
+          <a:chOff x="0" y="0"/>
+          <a:chExt cx="0" cy="0"/>
+        </a:xfrm>
+      </p:grpSpPr>
+      <p:sp>
+        <p:nvSpPr>
+          <p:cNvPr id="2" name="Header Placeholder 1"/>
+          <p:cNvSpPr>
+            <a:spLocks noGrp="1"/>
+          </p:cNvSpPr>
+          <p:nvPr>
+            <p:ph type="hdr" sz="quarter"/>
+          </p:nvPr>
+        </p:nvSpPr>
+        <p:spPr>
+          <a:xfrm>
+            <a:off x="0" y="0"/>
+            <a:ext cx="2971800" cy="457200"/>
+          </a:xfrm>
+          <a:prstGeom prst="rect">
+            <a:avLst/>
+          </a:prstGeom>
+        </p:spPr>
+        <p:txBody>
+          <a:bodyPr vert="horz" lIns="91440" tIns="45720" rIns="91440" bIns="45720" rtlCol="0"/>
+          <a:lstStyle>
+            <a:lvl1pPr algn="l">
+              <a:defRPr sz="1200"/>
+            </a:lvl1pPr>
+          </a:lstStyle>
+          <a:p>
+            <a:endParaRPr lang="en-US"/>
+          </a:p>
+        </p:txBody>
+      </p:sp>
+      <p:sp>
+        <p:nvSpPr>
+          <p:cNvPr id="3" name="Date Placeholder 2"/>
+          <p:cNvSpPr>
+            <a:spLocks noGrp="1"/>
+          </p:cNvSpPr>
+          <p:nvPr>
+            <p:ph type="dt" idx="1"/>
+          </p:nvPr>
+        </p:nvSpPr>
+        <p:spPr>
+          <a:xfrm>
+            <a:off x="3884613" y="0"/>
+            <a:ext cx="2971800" cy="457200"/>
+          </a:xfrm>
+          <a:prstGeom prst="rect">
+            <a:avLst/>
+          </a:prstGeom>
+        </p:spPr>
+        <p:txBody>
+          <a:bodyPr vert="horz" lIns="91440" tIns="45720" rIns="91440" bIns="45720" rtlCol="0"/>
+          <a:lstStyle>
+            <a:lvl1pPr algn="r">
+              <a:defRPr sz="1200"/>
+            </a:lvl1pPr>
+          </a:lstStyle>
+          <a:p>
+            <a:fld id="{0F89C1C7-3DCD-1040-A9CF-14679D8B5DDD}" type="datetimeFigureOut">
+              <a:rPr lang="en-US" smtClean="0"/>
+              <a:t>10/17/16</a:t>
+            </a:fld>
+            <a:endParaRPr lang="en-US"/>
+          </a:p>
+        </p:txBody>
+      </p:sp>
+      <p:sp>
+        <p:nvSpPr>
+          <p:cNvPr id="4" name="Slide Image Placeholder 3"/>
+          <p:cNvSpPr>
+            <a:spLocks noGrp="1" noRot="1" noChangeAspect="1"/>
+          </p:cNvSpPr>
+          <p:nvPr>
+            <p:ph type="sldImg" idx="2"/>
+          </p:nvPr>
+        </p:nvSpPr>
+        <p:spPr>
+          <a:xfrm>
+            <a:off x="1143000" y="685800"/>
+            <a:ext cx="4572000" cy="3429000"/>
+          </a:xfrm>
+          <a:prstGeom prst="rect">
+            <a:avLst/>
+          </a:prstGeom>
+          <a:noFill/>
+          <a:ln w="12700">
+            <a:solidFill>
+              <a:prstClr val="black"/>
+            </a:solidFill>
+          </a:ln>
+        </p:spPr>
+        <p:txBody>
+          <a:bodyPr vert="horz" lIns="91440" tIns="45720" rIns="91440" bIns="45720" rtlCol="0" anchor="ctr"/>
+          <a:lstStyle/>
+          <a:p>
+            <a:endParaRPr lang="en-US"/>
+          </a:p>
+        </p:txBody>
+      </p:sp>
+      <p:sp>
+        <p:nvSpPr>
+          <p:cNvPr id="5" name="Notes Placeholder 4"/>
+          <p:cNvSpPr>
+            <a:spLocks noGrp="1"/>
+          </p:cNvSpPr>
+          <p:nvPr>
+            <p:ph type="body" sz="quarter" idx="3"/>
+          </p:nvPr>
+        </p:nvSpPr>
+        <p:spPr>
+          <a:xfrm>
+            <a:off x="685800" y="4343400"/>
+            <a:ext cx="5486400" cy="4114800"/>
+          </a:xfrm>
+          <a:prstGeom prst="rect">
+            <a:avLst/>
+          </a:prstGeom>
+        </p:spPr>
+        <p:txBody>
+          <a:bodyPr vert="horz" lIns="91440" tIns="45720" rIns="91440" bIns="45720" rtlCol="0"/>
+          <a:lstStyle/>
+          <a:p>
+            <a:pPr lvl="0"/>
+            <a:r>
+              <a:rPr lang="en-US" smtClean="0"/>
+              <a:t>Click to edit Master text styles</a:t>
+            </a:r>
+          </a:p>
+          <a:p>
+            <a:pPr lvl="1"/>
+            <a:r>
+              <a:rPr lang="en-US" smtClean="0"/>
+              <a:t>Second level</a:t>
+            </a:r>
+          </a:p>
+          <a:p>
+            <a:pPr lvl="2"/>
+            <a:r>
+              <a:rPr lang="en-US" smtClean="0"/>
+              <a:t>Third level</a:t>
+            </a:r>
+          </a:p>
+          <a:p>
+            <a:pPr lvl="3"/>
+            <a:r>
+              <a:rPr lang="en-US" smtClean="0"/>
+              <a:t>Fourth level</a:t>
+            </a:r>
+          </a:p>
+          <a:p>
+            <a:pPr lvl="4"/>
+            <a:r>
+              <a:rPr lang="en-US" smtClean="0"/>
+              <a:t>Fifth level</a:t>
+            </a:r>
+            <a:endParaRPr lang="en-US"/>
+          </a:p>
+        </p:txBody>
+      </p:sp>
+      <p:sp>
+        <p:nvSpPr>
+          <p:cNvPr id="6" name="Footer Placeholder 5"/>
+          <p:cNvSpPr>
+            <a:spLocks noGrp="1"/>
+          </p:cNvSpPr>
+          <p:nvPr>
+            <p:ph type="ftr" sz="quarter" idx="4"/>
+          </p:nvPr>
+        </p:nvSpPr>
+        <p:spPr>
+          <a:xfrm>
+            <a:off x="0" y="8685213"/>
+            <a:ext cx="2971800" cy="457200"/>
+          </a:xfrm>
+          <a:prstGeom prst="rect">
+            <a:avLst/>
+          </a:prstGeom>
+        </p:spPr>
+        <p:txBody>
+          <a:bodyPr vert="horz" lIns="91440" tIns="45720" rIns="91440" bIns="45720" rtlCol="0" anchor="b"/>
+          <a:lstStyle>
+            <a:lvl1pPr algn="l">
+              <a:defRPr sz="1200"/>
+            </a:lvl1pPr>
+          </a:lstStyle>
+          <a:p>
+            <a:endParaRPr lang="en-US"/>
+          </a:p>
+        </p:txBody>
+      </p:sp>
+      <p:sp>
+        <p:nvSpPr>
+          <p:cNvPr id="7" name="Slide Number Placeholder 6"/>
+          <p:cNvSpPr>
+            <a:spLocks noGrp="1"/>
+          </p:cNvSpPr>
+          <p:nvPr>
+            <p:ph type="sldNum" sz="quarter" idx="5"/>
+          </p:nvPr>
+        </p:nvSpPr>
+        <p:spPr>
+          <a:xfrm>
+            <a:off x="3884613" y="8685213"/>
+            <a:ext cx="2971800" cy="457200"/>
+          </a:xfrm>
+          <a:prstGeom prst="rect">
+            <a:avLst/>
+          </a:prstGeom>
+        </p:spPr>
+        <p:txBody>
+          <a:bodyPr vert="horz" lIns="91440" tIns="45720" rIns="91440" bIns="45720" rtlCol="0" anchor="b"/>
+          <a:lstStyle>
+            <a:lvl1pPr algn="r">
+              <a:defRPr sz="1200"/>
+            </a:lvl1pPr>
+          </a:lstStyle>
+          <a:p>
+            <a:fld id="{BB5E49A5-4136-284D-997B-48E1D791AD67}" type="slidenum">
+              <a:rPr lang="en-US" smtClean="0"/>
+              <a:t>‹#›</a:t>
+            </a:fld>
+            <a:endParaRPr lang="en-US"/>
+          </a:p>
+        </p:txBody>
+      </p:sp>
+    </p:spTree>
+    <p:extLst>
+      <p:ext uri="{BB962C8B-B14F-4D97-AF65-F5344CB8AC3E}">
+        <p14:creationId xmlns:p14="http://schemas.microsoft.com/office/powerpoint/2010/main" val="2623252185"/>
+      </p:ext>
+    </p:extLst>
+  </p:cSld>
+  <p:clrMap bg1="lt1" tx1="dk1" bg2="lt2" tx2="dk2" accent1="accent1" accent2="accent2" accent3="accent3" accent4="accent4" accent5="accent5" accent6="accent6" hlink="hlink" folHlink="folHlink"/>
+  <p:notesStyle>
+    <a:lvl1pPr marL="0" algn="l" defTabSz="457200" rtl="0" eaLnBrk="1" latinLnBrk="0" hangingPunct="1">
+      <a:defRPr sz="1200" kern="1200">
+        <a:solidFill>
+          <a:schemeClr val="tx1"/>
+        </a:solidFill>
+        <a:latin typeface="+mn-lt"/>
+        <a:ea typeface="+mn-ea"/>
+        <a:cs typeface="+mn-cs"/>
+      </a:defRPr>
+    </a:lvl1pPr>
+    <a:lvl2pPr marL="457200" algn="l" defTabSz="457200" rtl="0" eaLnBrk="1" latinLnBrk="0" hangingPunct="1">
+      <a:defRPr sz="1200" kern="1200">
+        <a:solidFill>
+          <a:schemeClr val="tx1"/>
+        </a:solidFill>
+        <a:latin typeface="+mn-lt"/>
+        <a:ea typeface="+mn-ea"/>
+        <a:cs typeface="+mn-cs"/>
+      </a:defRPr>
+    </a:lvl2pPr>
+    <a:lvl3pPr marL="914400" algn="l" defTabSz="457200" rtl="0" eaLnBrk="1" latinLnBrk="0" hangingPunct="1">
+      <a:defRPr sz="1200" kern="1200">
+        <a:solidFill>
+          <a:schemeClr val="tx1"/>
+        </a:solidFill>
+        <a:latin typeface="+mn-lt"/>
+        <a:ea typeface="+mn-ea"/>
+        <a:cs typeface="+mn-cs"/>
+      </a:defRPr>
+    </a:lvl3pPr>
+    <a:lvl4pPr marL="1371600" algn="l" defTabSz="457200" rtl="0" eaLnBrk="1" latinLnBrk="0" hangingPunct="1">
+      <a:defRPr sz="1200" kern="1200">
+        <a:solidFill>
+          <a:schemeClr val="tx1"/>
+        </a:solidFill>
+        <a:latin typeface="+mn-lt"/>
+        <a:ea typeface="+mn-ea"/>
+        <a:cs typeface="+mn-cs"/>
+      </a:defRPr>
+    </a:lvl4pPr>
+    <a:lvl5pPr marL="1828800" algn="l" defTabSz="457200" rtl="0" eaLnBrk="1" latinLnBrk="0" hangingPunct="1">
+      <a:defRPr sz="1200" kern="1200">
+        <a:solidFill>
+          <a:schemeClr val="tx1"/>
+        </a:solidFill>
+        <a:latin typeface="+mn-lt"/>
+        <a:ea typeface="+mn-ea"/>
+        <a:cs typeface="+mn-cs"/>
+      </a:defRPr>
+    </a:lvl5pPr>
+    <a:lvl6pPr marL="2286000" algn="l" defTabSz="457200" rtl="0" eaLnBrk="1" latinLnBrk="0" hangingPunct="1">
+      <a:defRPr sz="1200" kern="1200">
+        <a:solidFill>
+          <a:schemeClr val="tx1"/>
+        </a:solidFill>
+        <a:latin typeface="+mn-lt"/>
+        <a:ea typeface="+mn-ea"/>
+        <a:cs typeface="+mn-cs"/>
+      </a:defRPr>
+    </a:lvl6pPr>
+    <a:lvl7pPr marL="2743200" algn="l" defTabSz="457200" rtl="0" eaLnBrk="1" latinLnBrk="0" hangingPunct="1">
+      <a:defRPr sz="1200" kern="1200">
+        <a:solidFill>
+          <a:schemeClr val="tx1"/>
+        </a:solidFill>
+        <a:latin typeface="+mn-lt"/>
+        <a:ea typeface="+mn-ea"/>
+        <a:cs typeface="+mn-cs"/>
+      </a:defRPr>
+    </a:lvl7pPr>
+    <a:lvl8pPr marL="3200400" algn="l" defTabSz="457200" rtl="0" eaLnBrk="1" latinLnBrk="0" hangingPunct="1">
+      <a:defRPr sz="1200" kern="1200">
+        <a:solidFill>
+          <a:schemeClr val="tx1"/>
+        </a:solidFill>
+        <a:latin typeface="+mn-lt"/>
+        <a:ea typeface="+mn-ea"/>
+        <a:cs typeface="+mn-cs"/>
+      </a:defRPr>
+    </a:lvl8pPr>
+    <a:lvl9pPr marL="3657600" algn="l" defTabSz="457200" rtl="0" eaLnBrk="1" latinLnBrk="0" hangingPunct="1">
+      <a:defRPr sz="1200" kern="1200">
+        <a:solidFill>
+          <a:schemeClr val="tx1"/>
+        </a:solidFill>
+        <a:latin typeface="+mn-lt"/>
+        <a:ea typeface="+mn-ea"/>
+        <a:cs typeface="+mn-cs"/>
+      </a:defRPr>
+    </a:lvl9pPr>
+  </p:notesStyle>
+</p:notesMaster>
+</file>
+
+<file path=ppt/notesSlides/notesSlide1.xml><?xml version="1.0" encoding="utf-8"?>
+<p:notes xmlns:a="http://schemas.openxmlformats.org/drawingml/2006/main" xmlns:p="http://schemas.openxmlformats.org/presentationml/2006/main" xmlns:r="http://schemas.openxmlformats.org/officeDocument/2006/relationships">
+  <p:cSld>
+    <p:spTree>
+      <p:nvGrpSpPr>
+        <p:cNvPr id="1" name=""/>
+        <p:cNvGrpSpPr/>
+        <p:nvPr/>
+      </p:nvGrpSpPr>
+      <p:grpSpPr>
+        <a:xfrm>
+          <a:off x="0" y="0"/>
+          <a:ext cx="0" cy="0"/>
+          <a:chOff x="0" y="0"/>
+          <a:chExt cx="0" cy="0"/>
+        </a:xfrm>
+      </p:grpSpPr>
+      <p:sp>
+        <p:nvSpPr>
+          <p:cNvPr id="2" name="Slide Image Placeholder 1"/>
+          <p:cNvSpPr>
+            <a:spLocks noGrp="1"/>
+          </p:cNvSpPr>
+          <p:nvPr>
+            <p:ph type="sldImg" idx="2"/>
+          </p:nvPr>
+        </p:nvSpPr>
+        <p:spPr/>
+      </p:sp>
+      <p:sp>
+        <p:nvSpPr>
+          <p:cNvPr id="3" name="Notes Placeholder 2"/>
+          <p:cNvSpPr>
+            <a:spLocks noGrp="1"/>
+          </p:cNvSpPr>
+          <p:nvPr>
+            <p:ph type="body" idx="3" sz="quarter"/>
+          </p:nvPr>
+        </p:nvSpPr>
+        <p:spPr/>
+        <p:txBody>
+          <a:bodyPr/>
+          <a:lstStyle/>
+          <a:p>
+            <a:r>
+              <a:t>Before Prompt 1, prime the chat once:</a:t>
+            </a:r>
+          </a:p>
+          <a:p>
+            <a:r>
+              <a:t>"We're running a live workshop. Keep each answer concise and skimmable — bullets over prose."</a:t>
+            </a:r>
+          </a:p>
+          <a:p/>
+          <a:p>
+            <a:r>
+              <a:t>PROMPT 1 — Requirements  (paste into the AI live)</a:t>
+            </a:r>
+          </a:p>
+          <a:p/>
+          <a:p>
+            <a:r>
+              <a:t>You are a senior automotive systems engineer. We are designing a Driver Monitoring System (DMS) that detects when a driver is drowsy, distracted, or experiencing a medical emergency, and responds appropriately. Generate:</a:t>
+            </a:r>
+          </a:p>
+          <a:p>
+            <a:r>
+              <a:t>- Stakeholder needs</a:t>
+            </a:r>
+          </a:p>
+          <a:p>
+            <a:r>
+              <a:t>- Functional requirements</a:t>
+            </a:r>
+          </a:p>
+          <a:p>
+            <a:r>
+              <a:t>- Non-functional requirements (latency, accuracy, privacy)</a:t>
+            </a:r>
+          </a:p>
+          <a:p>
+            <a:r>
+              <a:t>- Constraints</a:t>
+            </a:r>
+          </a:p>
+          <a:p>
+            <a:r>
+              <a:t>- Assumptions</a:t>
+            </a:r>
+          </a:p>
+          <a:p>
+            <a:r>
+              <a:t>- Acceptance criteria</a:t>
+            </a:r>
+          </a:p>
+          <a:p>
+            <a:r>
+              <a:t>Format the output as a requirements specification.</a:t>
+            </a:r>
+          </a:p>
+          <a:p/>
+          <a:p>
+            <a:r>
+              <a:t>ASK THE ROOM: What's missing? What would you challenge?</a:t>
+            </a:r>
+          </a:p>
+        </p:txBody>
+      </p:sp>
+      <p:sp>
+        <p:nvSpPr>
+          <p:cNvPr id="4" name="Slide Number Placeholder 3"/>
+          <p:cNvSpPr>
+            <a:spLocks noGrp="1"/>
+          </p:cNvSpPr>
+          <p:nvPr>
+            <p:ph type="sldNum" idx="5" sz="quarter"/>
+          </p:nvPr>
+        </p:nvSpPr>
+        <p:spPr/>
+      </p:sp>
+    </p:spTree>
+  </p:cSld>
+  <p:clrMapOvr>
+    <a:masterClrMapping/>
+  </p:clrMapOvr>
+</p:notes>
+</file>
+
+<file path=ppt/notesSlides/notesSlide2.xml><?xml version="1.0" encoding="utf-8"?>
+<p:notes xmlns:a="http://schemas.openxmlformats.org/drawingml/2006/main" xmlns:p="http://schemas.openxmlformats.org/presentationml/2006/main" xmlns:r="http://schemas.openxmlformats.org/officeDocument/2006/relationships">
+  <p:cSld>
+    <p:spTree>
+      <p:nvGrpSpPr>
+        <p:cNvPr id="1" name=""/>
+        <p:cNvGrpSpPr/>
+        <p:nvPr/>
+      </p:nvGrpSpPr>
+      <p:grpSpPr>
+        <a:xfrm>
+          <a:off x="0" y="0"/>
+          <a:ext cx="0" cy="0"/>
+          <a:chOff x="0" y="0"/>
+          <a:chExt cx="0" cy="0"/>
+        </a:xfrm>
+      </p:grpSpPr>
+      <p:sp>
+        <p:nvSpPr>
+          <p:cNvPr id="2" name="Slide Image Placeholder 1"/>
+          <p:cNvSpPr>
+            <a:spLocks noGrp="1"/>
+          </p:cNvSpPr>
+          <p:nvPr>
+            <p:ph type="sldImg" idx="2"/>
+          </p:nvPr>
+        </p:nvSpPr>
+        <p:spPr/>
+      </p:sp>
+      <p:sp>
+        <p:nvSpPr>
+          <p:cNvPr id="3" name="Notes Placeholder 2"/>
+          <p:cNvSpPr>
+            <a:spLocks noGrp="1"/>
+          </p:cNvSpPr>
+          <p:nvPr>
+            <p:ph type="body" idx="3" sz="quarter"/>
+          </p:nvPr>
+        </p:nvSpPr>
+        <p:spPr/>
+        <p:txBody>
+          <a:bodyPr/>
+          <a:lstStyle/>
+          <a:p>
+            <a:r>
+              <a:t>PROMPT 2 — Architecture &amp; Design</a:t>
+            </a:r>
+          </a:p>
+          <a:p/>
+          <a:p>
+            <a:r>
+              <a:t>Using the approved requirements, create a concise architecture description including:</a:t>
+            </a:r>
+          </a:p>
+          <a:p>
+            <a:r>
+              <a:t>- System context diagram (described in text)</a:t>
+            </a:r>
+          </a:p>
+          <a:p>
+            <a:r>
+              <a:t>- Major components (sensors, perception/AI, decision logic, HMI, vehicle interface)</a:t>
+            </a:r>
+          </a:p>
+          <a:p>
+            <a:r>
+              <a:t>- Interfaces and data flows</a:t>
+            </a:r>
+          </a:p>
+          <a:p>
+            <a:r>
+              <a:t>- Failure modes</a:t>
+            </a:r>
+          </a:p>
+          <a:p>
+            <a:r>
+              <a:t>- Safety considerations</a:t>
+            </a:r>
+          </a:p>
+          <a:p>
+            <a:r>
+              <a:t>- Privacy and cybersecurity considerations</a:t>
+            </a:r>
+          </a:p>
+          <a:p/>
+          <a:p>
+            <a:r>
+              <a:t>ASK THE ROOM: Where could this go wrong, and how would the system stay safe?</a:t>
+            </a:r>
+          </a:p>
+        </p:txBody>
+      </p:sp>
+      <p:sp>
+        <p:nvSpPr>
+          <p:cNvPr id="4" name="Slide Number Placeholder 3"/>
+          <p:cNvSpPr>
+            <a:spLocks noGrp="1"/>
+          </p:cNvSpPr>
+          <p:nvPr>
+            <p:ph type="sldNum" idx="5" sz="quarter"/>
+          </p:nvPr>
+        </p:nvSpPr>
+        <p:spPr/>
+      </p:sp>
+    </p:spTree>
+  </p:cSld>
+  <p:clrMapOvr>
+    <a:masterClrMapping/>
+  </p:clrMapOvr>
+</p:notes>
+</file>
+
+<file path=ppt/notesSlides/notesSlide3.xml><?xml version="1.0" encoding="utf-8"?>
+<p:notes xmlns:a="http://schemas.openxmlformats.org/drawingml/2006/main" xmlns:p="http://schemas.openxmlformats.org/presentationml/2006/main" xmlns:r="http://schemas.openxmlformats.org/officeDocument/2006/relationships">
+  <p:cSld>
+    <p:spTree>
+      <p:nvGrpSpPr>
+        <p:cNvPr id="1" name=""/>
+        <p:cNvGrpSpPr/>
+        <p:nvPr/>
+      </p:nvGrpSpPr>
+      <p:grpSpPr>
+        <a:xfrm>
+          <a:off x="0" y="0"/>
+          <a:ext cx="0" cy="0"/>
+          <a:chOff x="0" y="0"/>
+          <a:chExt cx="0" cy="0"/>
+        </a:xfrm>
+      </p:grpSpPr>
+      <p:sp>
+        <p:nvSpPr>
+          <p:cNvPr id="2" name="Slide Image Placeholder 1"/>
+          <p:cNvSpPr>
+            <a:spLocks noGrp="1"/>
+          </p:cNvSpPr>
+          <p:nvPr>
+            <p:ph type="sldImg" idx="2"/>
+          </p:nvPr>
+        </p:nvSpPr>
+        <p:spPr/>
+      </p:sp>
+      <p:sp>
+        <p:nvSpPr>
+          <p:cNvPr id="3" name="Notes Placeholder 2"/>
+          <p:cNvSpPr>
+            <a:spLocks noGrp="1"/>
+          </p:cNvSpPr>
+          <p:nvPr>
+            <p:ph type="body" idx="3" sz="quarter"/>
+          </p:nvPr>
+        </p:nvSpPr>
+        <p:spPr/>
+        <p:txBody>
+          <a:bodyPr/>
+          <a:lstStyle/>
+          <a:p>
+            <a:r>
+              <a:t>PROMPT 3 — SysML v2 Text Model</a:t>
+            </a:r>
+          </a:p>
+          <a:p/>
+          <a:p>
+            <a:r>
+              <a:t>Using the architecture, generate a simple SysML v2 textual model including:</a:t>
+            </a:r>
+          </a:p>
+          <a:p>
+            <a:r>
+              <a:t>- Requirements</a:t>
+            </a:r>
+          </a:p>
+          <a:p>
+            <a:r>
+              <a:t>- Actions/functions (e.g., DetectDrowsiness, AssessConfidence, TriggerResponse)</a:t>
+            </a:r>
+          </a:p>
+          <a:p>
+            <a:r>
+              <a:t>- Interfaces/flows</a:t>
+            </a:r>
+          </a:p>
+          <a:p>
+            <a:r>
+              <a:t>- Major system elements</a:t>
+            </a:r>
+          </a:p>
+          <a:p>
+            <a:r>
+              <a:t>Focus on readability, not tool-specific correctness.</a:t>
+            </a:r>
+          </a:p>
+          <a:p/>
+          <a:p>
+            <a:r>
+              <a:t>ASK THE ROOM: This is just a structured way to write the design so a person AND a machine can read it — note how it traces back to the requirements.</a:t>
+            </a:r>
+          </a:p>
+        </p:txBody>
+      </p:sp>
+      <p:sp>
+        <p:nvSpPr>
+          <p:cNvPr id="4" name="Slide Number Placeholder 3"/>
+          <p:cNvSpPr>
+            <a:spLocks noGrp="1"/>
+          </p:cNvSpPr>
+          <p:nvPr>
+            <p:ph type="sldNum" idx="5" sz="quarter"/>
+          </p:nvPr>
+        </p:nvSpPr>
+        <p:spPr/>
+      </p:sp>
+    </p:spTree>
+  </p:cSld>
+  <p:clrMapOvr>
+    <a:masterClrMapping/>
+  </p:clrMapOvr>
+</p:notes>
+</file>
+
+<file path=ppt/notesSlides/notesSlide4.xml><?xml version="1.0" encoding="utf-8"?>
+<p:notes xmlns:a="http://schemas.openxmlformats.org/drawingml/2006/main" xmlns:p="http://schemas.openxmlformats.org/presentationml/2006/main" xmlns:r="http://schemas.openxmlformats.org/officeDocument/2006/relationships">
+  <p:cSld>
+    <p:spTree>
+      <p:nvGrpSpPr>
+        <p:cNvPr id="1" name=""/>
+        <p:cNvGrpSpPr/>
+        <p:nvPr/>
+      </p:nvGrpSpPr>
+      <p:grpSpPr>
+        <a:xfrm>
+          <a:off x="0" y="0"/>
+          <a:ext cx="0" cy="0"/>
+          <a:chOff x="0" y="0"/>
+          <a:chExt cx="0" cy="0"/>
+        </a:xfrm>
+      </p:grpSpPr>
+      <p:sp>
+        <p:nvSpPr>
+          <p:cNvPr id="2" name="Slide Image Placeholder 1"/>
+          <p:cNvSpPr>
+            <a:spLocks noGrp="1"/>
+          </p:cNvSpPr>
+          <p:nvPr>
+            <p:ph type="sldImg" idx="2"/>
+          </p:nvPr>
+        </p:nvSpPr>
+        <p:spPr/>
+      </p:sp>
+      <p:sp>
+        <p:nvSpPr>
+          <p:cNvPr id="3" name="Notes Placeholder 2"/>
+          <p:cNvSpPr>
+            <a:spLocks noGrp="1"/>
+          </p:cNvSpPr>
+          <p:nvPr>
+            <p:ph type="body" idx="3" sz="quarter"/>
+          </p:nvPr>
+        </p:nvSpPr>
+        <p:spPr/>
+        <p:txBody>
+          <a:bodyPr/>
+          <a:lstStyle/>
+          <a:p>
+            <a:r>
+              <a:t>PROMPT 4 — Test Development</a:t>
+            </a:r>
+          </a:p>
+          <a:p/>
+          <a:p>
+            <a:r>
+              <a:t>Create:</a:t>
+            </a:r>
+          </a:p>
+          <a:p>
+            <a:r>
+              <a:t>- Verification strategy</a:t>
+            </a:r>
+          </a:p>
+          <a:p>
+            <a:r>
+              <a:t>- Functional test cases</a:t>
+            </a:r>
+          </a:p>
+          <a:p>
+            <a:r>
+              <a:t>- Edge case test cases (sunglasses, darkness, head turned, passenger interference)</a:t>
+            </a:r>
+          </a:p>
+          <a:p>
+            <a:r>
+              <a:t>- Negative test cases (false-positive drowsiness)</a:t>
+            </a:r>
+          </a:p>
+          <a:p>
+            <a:r>
+              <a:t>- A requirements-to-test traceability matrix</a:t>
+            </a:r>
+          </a:p>
+          <a:p>
+            <a:r>
+              <a:t>Include objective pass/fail criteria.</a:t>
+            </a:r>
+          </a:p>
+          <a:p/>
+          <a:p>
+            <a:r>
+              <a:t>ASK THE ROOM: Which of these tests would you most want to see pass before shipping?</a:t>
+            </a:r>
+          </a:p>
+        </p:txBody>
+      </p:sp>
+      <p:sp>
+        <p:nvSpPr>
+          <p:cNvPr id="4" name="Slide Number Placeholder 3"/>
+          <p:cNvSpPr>
+            <a:spLocks noGrp="1"/>
+          </p:cNvSpPr>
+          <p:nvPr>
+            <p:ph type="sldNum" idx="5" sz="quarter"/>
+          </p:nvPr>
+        </p:nvSpPr>
+        <p:spPr/>
+      </p:sp>
+    </p:spTree>
+  </p:cSld>
+  <p:clrMapOvr>
+    <a:masterClrMapping/>
+  </p:clrMapOvr>
+</p:notes>
+</file>
+
+<file path=ppt/notesSlides/notesSlide5.xml><?xml version="1.0" encoding="utf-8"?>
+<p:notes xmlns:a="http://schemas.openxmlformats.org/drawingml/2006/main" xmlns:p="http://schemas.openxmlformats.org/presentationml/2006/main" xmlns:r="http://schemas.openxmlformats.org/officeDocument/2006/relationships">
+  <p:cSld>
+    <p:spTree>
+      <p:nvGrpSpPr>
+        <p:cNvPr id="1" name=""/>
+        <p:cNvGrpSpPr/>
+        <p:nvPr/>
+      </p:nvGrpSpPr>
+      <p:grpSpPr>
+        <a:xfrm>
+          <a:off x="0" y="0"/>
+          <a:ext cx="0" cy="0"/>
+          <a:chOff x="0" y="0"/>
+          <a:chExt cx="0" cy="0"/>
+        </a:xfrm>
+      </p:grpSpPr>
+      <p:sp>
+        <p:nvSpPr>
+          <p:cNvPr id="2" name="Slide Image Placeholder 1"/>
+          <p:cNvSpPr>
+            <a:spLocks noGrp="1"/>
+          </p:cNvSpPr>
+          <p:nvPr>
+            <p:ph type="sldImg" idx="2"/>
+          </p:nvPr>
+        </p:nvSpPr>
+        <p:spPr/>
+      </p:sp>
+      <p:sp>
+        <p:nvSpPr>
+          <p:cNvPr id="3" name="Notes Placeholder 2"/>
+          <p:cNvSpPr>
+            <a:spLocks noGrp="1"/>
+          </p:cNvSpPr>
+          <p:nvPr>
+            <p:ph type="body" idx="3" sz="quarter"/>
+          </p:nvPr>
+        </p:nvSpPr>
+        <p:spPr/>
+        <p:txBody>
+          <a:bodyPr/>
+          <a:lstStyle/>
+          <a:p>
+            <a:r>
+              <a:t>PROMPT 5 — Implementation Approach</a:t>
+            </a:r>
+          </a:p>
+          <a:p/>
+          <a:p>
+            <a:r>
+              <a:t>Generate:</a:t>
+            </a:r>
+          </a:p>
+          <a:p>
+            <a:r>
+              <a:t>- High-level implementation approach</a:t>
+            </a:r>
+          </a:p>
+          <a:p>
+            <a:r>
+              <a:t>- Pseudocode for the detect-assess-respond loop</a:t>
+            </a:r>
+          </a:p>
+          <a:p>
+            <a:r>
+              <a:t>- Logic flow</a:t>
+            </a:r>
+          </a:p>
+          <a:p>
+            <a:r>
+              <a:t>- Data processing steps</a:t>
+            </a:r>
+          </a:p>
+          <a:p>
+            <a:r>
+              <a:t>- Assumptions</a:t>
+            </a:r>
+          </a:p>
+          <a:p>
+            <a:r>
+              <a:t>Explain how the solution satisfies the requirements.</a:t>
+            </a:r>
+          </a:p>
+          <a:p/>
+          <a:p>
+            <a:r>
+              <a:t>ASK: Notice we went from idea to logic with no separate dev-team handoff.</a:t>
+            </a:r>
+          </a:p>
+          <a:p/>
+          <a:p>
+            <a:r>
+              <a:t>----------</a:t>
+            </a:r>
+          </a:p>
+          <a:p/>
+          <a:p>
+            <a:r>
+              <a:t>PROMPT 6 — Verification Review</a:t>
+            </a:r>
+          </a:p>
+          <a:p/>
+          <a:p>
+            <a:r>
+              <a:t>Review the proposed implementation. Identify:</a:t>
+            </a:r>
+          </a:p>
+          <a:p>
+            <a:r>
+              <a:t>- Which requirements are satisfied</a:t>
+            </a:r>
+          </a:p>
+          <a:p>
+            <a:r>
+              <a:t>- Which tests would pass</a:t>
+            </a:r>
+          </a:p>
+          <a:p>
+            <a:r>
+              <a:t>- Potential defects</a:t>
+            </a:r>
+          </a:p>
+          <a:p>
+            <a:r>
+              <a:t>- Risks (false alarms and missed detections)</a:t>
+            </a:r>
+          </a:p>
+          <a:p>
+            <a:r>
+              <a:t>- Recommended improvements</a:t>
+            </a:r>
+          </a:p>
+          <a:p>
+            <a:r>
+              <a:t>Provide a pass/fail assessment.</a:t>
+            </a:r>
+          </a:p>
+          <a:p/>
+          <a:p>
+            <a:r>
+              <a:t>ASK THE ROOM: Where does human expertise still have to make the final call?</a:t>
+            </a:r>
+          </a:p>
+        </p:txBody>
+      </p:sp>
+      <p:sp>
+        <p:nvSpPr>
+          <p:cNvPr id="4" name="Slide Number Placeholder 3"/>
+          <p:cNvSpPr>
+            <a:spLocks noGrp="1"/>
+          </p:cNvSpPr>
+          <p:nvPr>
+            <p:ph type="sldNum" idx="5" sz="quarter"/>
+          </p:nvPr>
+        </p:nvSpPr>
+        <p:spPr/>
+      </p:sp>
+    </p:spTree>
+  </p:cSld>
+  <p:clrMapOvr>
+    <a:masterClrMapping/>
+  </p:clrMapOvr>
+</p:notes>
+</file>
+
+<file path=ppt/notesSlides/notesSlide6.xml><?xml version="1.0" encoding="utf-8"?>
+<p:notes xmlns:a="http://schemas.openxmlformats.org/drawingml/2006/main" xmlns:p="http://schemas.openxmlformats.org/presentationml/2006/main" xmlns:r="http://schemas.openxmlformats.org/officeDocument/2006/relationships">
+  <p:cSld>
+    <p:spTree>
+      <p:nvGrpSpPr>
+        <p:cNvPr id="1" name=""/>
+        <p:cNvGrpSpPr/>
+        <p:nvPr/>
+      </p:nvGrpSpPr>
+      <p:grpSpPr>
+        <a:xfrm>
+          <a:off x="0" y="0"/>
+          <a:ext cx="0" cy="0"/>
+          <a:chOff x="0" y="0"/>
+          <a:chExt cx="0" cy="0"/>
+        </a:xfrm>
+      </p:grpSpPr>
+      <p:sp>
+        <p:nvSpPr>
+          <p:cNvPr id="2" name="Slide Image Placeholder 1"/>
+          <p:cNvSpPr>
+            <a:spLocks noGrp="1"/>
+          </p:cNvSpPr>
+          <p:nvPr>
+            <p:ph type="sldImg" idx="2"/>
+          </p:nvPr>
+        </p:nvSpPr>
+        <p:spPr/>
+      </p:sp>
+      <p:sp>
+        <p:nvSpPr>
+          <p:cNvPr id="3" name="Notes Placeholder 2"/>
+          <p:cNvSpPr>
+            <a:spLocks noGrp="1"/>
+          </p:cNvSpPr>
+          <p:nvPr>
+            <p:ph type="body" idx="3" sz="quarter"/>
+          </p:nvPr>
+        </p:nvSpPr>
+        <p:spPr/>
+        <p:txBody>
+          <a:bodyPr/>
+          <a:lstStyle/>
+          <a:p>
+            <a:r>
+              <a:t>PROMPT 7 — Deployment Planning</a:t>
+            </a:r>
+          </a:p>
+          <a:p/>
+          <a:p>
+            <a:r>
+              <a:t>Create:</a:t>
+            </a:r>
+          </a:p>
+          <a:p>
+            <a:r>
+              <a:t>- OTA deployment plan</a:t>
+            </a:r>
+          </a:p>
+          <a:p>
+            <a:r>
+              <a:t>- Rollback strategy</a:t>
+            </a:r>
+          </a:p>
+          <a:p>
+            <a:r>
+              <a:t>- Monitoring metrics (detection accuracy, false-alarm rate, driver trust signals)</a:t>
+            </a:r>
+          </a:p>
+          <a:p>
+            <a:r>
+              <a:t>- Release notes</a:t>
+            </a:r>
+          </a:p>
+          <a:p>
+            <a:r>
+              <a:t>- Customer impact assessment</a:t>
+            </a:r>
+          </a:p>
+          <a:p>
+            <a:r>
+              <a:t>- Success criteria after deployment</a:t>
+            </a:r>
+          </a:p>
+          <a:p/>
+          <a:p>
+            <a:r>
+              <a:t>ASK THE ROOM: We just reached a deployment plan. How many teams would this normally take?</a:t>
+            </a:r>
+          </a:p>
+        </p:txBody>
+      </p:sp>
+      <p:sp>
+        <p:nvSpPr>
+          <p:cNvPr id="4" name="Slide Number Placeholder 3"/>
+          <p:cNvSpPr>
+            <a:spLocks noGrp="1"/>
+          </p:cNvSpPr>
+          <p:nvPr>
+            <p:ph type="sldNum" idx="5" sz="quarter"/>
+          </p:nvPr>
+        </p:nvSpPr>
+        <p:spPr/>
+      </p:sp>
+    </p:spTree>
+  </p:cSld>
+  <p:clrMapOvr>
+    <a:masterClrMapping/>
+  </p:clrMapOvr>
+</p:notes>
 </file>
 
 <file path=ppt/slideLayouts/slideLayout1.xml><?xml version="1.0" encoding="utf-8"?>
@@ -16064,4 +17151,324 @@
   </a:objectDefaults>
   <a:extraClrSchemeLst/>
 </a:theme>
+</file>
+
+<file path=ppt/theme/theme2.xml><?xml version="1.0" encoding="utf-8"?>
+<a:theme xmlns:a="http://schemas.openxmlformats.org/drawingml/2006/main" name="Office Theme">
+  <a:themeElements>
+    <a:clrScheme name="Office">
+      <a:dk1>
+        <a:sysClr val="windowText" lastClr="000000"/>
+      </a:dk1>
+      <a:lt1>
+        <a:sysClr val="window" lastClr="FFFFFF"/>
+      </a:lt1>
+      <a:dk2>
+        <a:srgbClr val="1F497D"/>
+      </a:dk2>
+      <a:lt2>
+        <a:srgbClr val="EEECE1"/>
+      </a:lt2>
+      <a:accent1>
+        <a:srgbClr val="4F81BD"/>
+      </a:accent1>
+      <a:accent2>
+        <a:srgbClr val="C0504D"/>
+      </a:accent2>
+      <a:accent3>
+        <a:srgbClr val="9BBB59"/>
+      </a:accent3>
+      <a:accent4>
+        <a:srgbClr val="8064A2"/>
+      </a:accent4>
+      <a:accent5>
+        <a:srgbClr val="4BACC6"/>
+      </a:accent5>
+      <a:accent6>
+        <a:srgbClr val="F79646"/>
+      </a:accent6>
+      <a:hlink>
+        <a:srgbClr val="0000FF"/>
+      </a:hlink>
+      <a:folHlink>
+        <a:srgbClr val="800080"/>
+      </a:folHlink>
+    </a:clrScheme>
+    <a:fontScheme name="Office">
+      <a:majorFont>
+        <a:latin typeface="Calibri"/>
+        <a:ea typeface=""/>
+        <a:cs typeface=""/>
+        <a:font script="Jpan" typeface="ＭＳ Ｐゴシック"/>
+        <a:font script="Hang" typeface="맑은 고딕"/>
+        <a:font script="Hans" typeface="宋体"/>
+        <a:font script="Hant" typeface="新細明體"/>
+        <a:font script="Arab" typeface="Times New Roman"/>
+        <a:font script="Hebr" typeface="Times New Roman"/>
+        <a:font script="Thai" typeface="Angsana New"/>
+        <a:font script="Ethi" typeface="Nyala"/>
+        <a:font script="Beng" typeface="Vrinda"/>
+        <a:font script="Gujr" typeface="Shruti"/>
+        <a:font script="Khmr" typeface="MoolBoran"/>
+        <a:font script="Knda" typeface="Tunga"/>
+        <a:font script="Guru" typeface="Raavi"/>
+        <a:font script="Cans" typeface="Euphemia"/>
+        <a:font script="Cher" typeface="Plantagenet Cherokee"/>
+        <a:font script="Yiii" typeface="Microsoft Yi Baiti"/>
+        <a:font script="Tibt" typeface="Microsoft Himalaya"/>
+        <a:font script="Thaa" typeface="MV Boli"/>
+        <a:font script="Deva" typeface="Mangal"/>
+        <a:font script="Telu" typeface="Gautami"/>
+        <a:font script="Taml" typeface="Latha"/>
+        <a:font script="Syrc" typeface="Estrangelo Edessa"/>
+        <a:font script="Orya" typeface="Kalinga"/>
+        <a:font script="Mlym" typeface="Kartika"/>
+        <a:font script="Laoo" typeface="DokChampa"/>
+        <a:font script="Sinh" typeface="Iskoola Pota"/>
+        <a:font script="Mong" typeface="Mongolian Baiti"/>
+        <a:font script="Viet" typeface="Times New Roman"/>
+        <a:font script="Uigh" typeface="Microsoft Uighur"/>
+        <a:font script="Geor" typeface="Sylfaen"/>
+      </a:majorFont>
+      <a:minorFont>
+        <a:latin typeface="Calibri"/>
+        <a:ea typeface=""/>
+        <a:cs typeface=""/>
+        <a:font script="Jpan" typeface="ＭＳ Ｐゴシック"/>
+        <a:font script="Hang" typeface="맑은 고딕"/>
+        <a:font script="Hans" typeface="宋体"/>
+        <a:font script="Hant" typeface="新細明體"/>
+        <a:font script="Arab" typeface="Arial"/>
+        <a:font script="Hebr" typeface="Arial"/>
+        <a:font script="Thai" typeface="Cordia New"/>
+        <a:font script="Ethi" typeface="Nyala"/>
+        <a:font script="Beng" typeface="Vrinda"/>
+        <a:font script="Gujr" typeface="Shruti"/>
+        <a:font script="Khmr" typeface="DaunPenh"/>
+        <a:font script="Knda" typeface="Tunga"/>
+        <a:font script="Guru" typeface="Raavi"/>
+        <a:font script="Cans" typeface="Euphemia"/>
+        <a:font script="Cher" typeface="Plantagenet Cherokee"/>
+        <a:font script="Yiii" typeface="Microsoft Yi Baiti"/>
+        <a:font script="Tibt" typeface="Microsoft Himalaya"/>
+        <a:font script="Thaa" typeface="MV Boli"/>
+        <a:font script="Deva" typeface="Mangal"/>
+        <a:font script="Telu" typeface="Gautami"/>
+        <a:font script="Taml" typeface="Latha"/>
+        <a:font script="Syrc" typeface="Estrangelo Edessa"/>
+        <a:font script="Orya" typeface="Kalinga"/>
+        <a:font script="Mlym" typeface="Kartika"/>
+        <a:font script="Laoo" typeface="DokChampa"/>
+        <a:font script="Sinh" typeface="Iskoola Pota"/>
+        <a:font script="Mong" typeface="Mongolian Baiti"/>
+        <a:font script="Viet" typeface="Arial"/>
+        <a:font script="Uigh" typeface="Microsoft Uighur"/>
+        <a:font script="Geor" typeface="Sylfaen"/>
+      </a:minorFont>
+    </a:fontScheme>
+    <a:fmtScheme name="Office">
+      <a:fillStyleLst>
+        <a:solidFill>
+          <a:schemeClr val="phClr"/>
+        </a:solidFill>
+        <a:gradFill rotWithShape="1">
+          <a:gsLst>
+            <a:gs pos="0">
+              <a:schemeClr val="phClr">
+                <a:tint val="50000"/>
+                <a:satMod val="300000"/>
+              </a:schemeClr>
+            </a:gs>
+            <a:gs pos="35000">
+              <a:schemeClr val="phClr">
+                <a:tint val="37000"/>
+                <a:satMod val="300000"/>
+              </a:schemeClr>
+            </a:gs>
+            <a:gs pos="100000">
+              <a:schemeClr val="phClr">
+                <a:tint val="15000"/>
+                <a:satMod val="350000"/>
+              </a:schemeClr>
+            </a:gs>
+          </a:gsLst>
+          <a:lin ang="16200000" scaled="1"/>
+        </a:gradFill>
+        <a:gradFill rotWithShape="1">
+          <a:gsLst>
+            <a:gs pos="0">
+              <a:schemeClr val="phClr">
+                <a:tint val="100000"/>
+                <a:shade val="100000"/>
+                <a:satMod val="130000"/>
+              </a:schemeClr>
+            </a:gs>
+            <a:gs pos="100000">
+              <a:schemeClr val="phClr">
+                <a:tint val="50000"/>
+                <a:shade val="100000"/>
+                <a:satMod val="350000"/>
+              </a:schemeClr>
+            </a:gs>
+          </a:gsLst>
+          <a:lin ang="16200000" scaled="0"/>
+        </a:gradFill>
+      </a:fillStyleLst>
+      <a:lnStyleLst>
+        <a:ln w="9525" cap="flat" cmpd="sng" algn="ctr">
+          <a:solidFill>
+            <a:schemeClr val="phClr">
+              <a:shade val="95000"/>
+              <a:satMod val="105000"/>
+            </a:schemeClr>
+          </a:solidFill>
+          <a:prstDash val="solid"/>
+        </a:ln>
+        <a:ln w="25400" cap="flat" cmpd="sng" algn="ctr">
+          <a:solidFill>
+            <a:schemeClr val="phClr"/>
+          </a:solidFill>
+          <a:prstDash val="solid"/>
+        </a:ln>
+        <a:ln w="38100" cap="flat" cmpd="sng" algn="ctr">
+          <a:solidFill>
+            <a:schemeClr val="phClr"/>
+          </a:solidFill>
+          <a:prstDash val="solid"/>
+        </a:ln>
+      </a:lnStyleLst>
+      <a:effectStyleLst>
+        <a:effectStyle>
+          <a:effectLst>
+            <a:outerShdw blurRad="40000" dist="20000" dir="5400000" rotWithShape="0">
+              <a:srgbClr val="000000">
+                <a:alpha val="38000"/>
+              </a:srgbClr>
+            </a:outerShdw>
+          </a:effectLst>
+        </a:effectStyle>
+        <a:effectStyle>
+          <a:effectLst>
+            <a:outerShdw blurRad="40000" dist="23000" dir="5400000" rotWithShape="0">
+              <a:srgbClr val="000000">
+                <a:alpha val="35000"/>
+              </a:srgbClr>
+            </a:outerShdw>
+          </a:effectLst>
+        </a:effectStyle>
+        <a:effectStyle>
+          <a:effectLst>
+            <a:outerShdw blurRad="40000" dist="23000" dir="5400000" rotWithShape="0">
+              <a:srgbClr val="000000">
+                <a:alpha val="35000"/>
+              </a:srgbClr>
+            </a:outerShdw>
+          </a:effectLst>
+          <a:scene3d>
+            <a:camera prst="orthographicFront">
+              <a:rot lat="0" lon="0" rev="0"/>
+            </a:camera>
+            <a:lightRig rig="threePt" dir="t">
+              <a:rot lat="0" lon="0" rev="1200000"/>
+            </a:lightRig>
+          </a:scene3d>
+          <a:sp3d>
+            <a:bevelT w="63500" h="25400"/>
+          </a:sp3d>
+        </a:effectStyle>
+      </a:effectStyleLst>
+      <a:bgFillStyleLst>
+        <a:solidFill>
+          <a:schemeClr val="phClr"/>
+        </a:solidFill>
+        <a:gradFill rotWithShape="1">
+          <a:gsLst>
+            <a:gs pos="0">
+              <a:schemeClr val="phClr">
+                <a:tint val="40000"/>
+                <a:satMod val="350000"/>
+              </a:schemeClr>
+            </a:gs>
+            <a:gs pos="40000">
+              <a:schemeClr val="phClr">
+                <a:tint val="45000"/>
+                <a:shade val="99000"/>
+                <a:satMod val="350000"/>
+              </a:schemeClr>
+            </a:gs>
+            <a:gs pos="100000">
+              <a:schemeClr val="phClr">
+                <a:shade val="20000"/>
+                <a:satMod val="255000"/>
+              </a:schemeClr>
+            </a:gs>
+          </a:gsLst>
+          <a:path path="circle">
+            <a:fillToRect l="50000" t="-80000" r="50000" b="180000"/>
+          </a:path>
+        </a:gradFill>
+        <a:gradFill rotWithShape="1">
+          <a:gsLst>
+            <a:gs pos="0">
+              <a:schemeClr val="phClr">
+                <a:tint val="80000"/>
+                <a:satMod val="300000"/>
+              </a:schemeClr>
+            </a:gs>
+            <a:gs pos="100000">
+              <a:schemeClr val="phClr">
+                <a:shade val="30000"/>
+                <a:satMod val="200000"/>
+              </a:schemeClr>
+            </a:gs>
+          </a:gsLst>
+          <a:path path="circle">
+            <a:fillToRect l="50000" t="50000" r="50000" b="50000"/>
+          </a:path>
+        </a:gradFill>
+      </a:bgFillStyleLst>
+    </a:fmtScheme>
+  </a:themeElements>
+  <a:objectDefaults>
+    <a:spDef>
+      <a:spPr/>
+      <a:bodyPr/>
+      <a:lstStyle/>
+      <a:style>
+        <a:lnRef idx="1">
+          <a:schemeClr val="accent1"/>
+        </a:lnRef>
+        <a:fillRef idx="3">
+          <a:schemeClr val="accent1"/>
+        </a:fillRef>
+        <a:effectRef idx="2">
+          <a:schemeClr val="accent1"/>
+        </a:effectRef>
+        <a:fontRef idx="minor">
+          <a:schemeClr val="lt1"/>
+        </a:fontRef>
+      </a:style>
+    </a:spDef>
+    <a:lnDef>
+      <a:spPr/>
+      <a:bodyPr/>
+      <a:lstStyle/>
+      <a:style>
+        <a:lnRef idx="2">
+          <a:schemeClr val="accent1"/>
+        </a:lnRef>
+        <a:fillRef idx="0">
+          <a:schemeClr val="accent1"/>
+        </a:fillRef>
+        <a:effectRef idx="1">
+          <a:schemeClr val="accent1"/>
+        </a:effectRef>
+        <a:fontRef idx="minor">
+          <a:schemeClr val="tx1"/>
+        </a:fontRef>
+      </a:style>
+    </a:lnDef>
+  </a:objectDefaults>
+  <a:extraClrSchemeLst/>
+</a:theme>
 </file>
</xml_diff>

<commit_message>
Add Gamma deck outline (prompts visible, directions in notes, no Mentimeter)
Also finalize pptx generator: prompt cards show the prompt for audience
follow-along; facilitator directions live only in speaker notes.

Co-Authored-By: Claude Opus 4.8 (1M context) <noreply@anthropic.com>
</commit_message>
<xml_diff>
--- a/dms-workshop/AI-Powered-Product-Development_DMS.pptx
+++ b/dms-workshop/AI-Powered-Product-Development_DMS.pptx
@@ -6117,7 +6117,7 @@
         <p:spPr>
           <a:xfrm>
             <a:off x="640080" y="1901952"/>
-            <a:ext cx="10881360" cy="3520440"/>
+            <a:ext cx="10881360" cy="4114800"/>
           </a:xfrm>
           <a:prstGeom prst="roundRect">
             <a:avLst/>
@@ -6242,7 +6242,7 @@
         <p:spPr>
           <a:xfrm>
             <a:off x="896112" y="2523744"/>
-            <a:ext cx="10369296" cy="2743200"/>
+            <a:ext cx="10369296" cy="3337560"/>
           </a:xfrm>
           <a:prstGeom prst="rect">
             <a:avLst/>
@@ -6257,7 +6257,7 @@
           <a:p>
             <a:pPr algn="l"/>
             <a:r>
-              <a:rPr sz="1500" b="0" i="0">
+              <a:rPr sz="1600" b="0" i="0">
                 <a:solidFill>
                   <a:srgbClr val="1B1B1B"/>
                 </a:solidFill>
@@ -6269,7 +6269,7 @@
           <a:p>
             <a:pPr algn="l"/>
             <a:r>
-              <a:rPr sz="1500" b="0" i="0">
+              <a:rPr sz="1600" b="0" i="0">
                 <a:solidFill>
                   <a:srgbClr val="1B1B1B"/>
                 </a:solidFill>
@@ -6281,7 +6281,7 @@
           <a:p>
             <a:pPr algn="l"/>
             <a:r>
-              <a:rPr sz="1500" b="0" i="0">
+              <a:rPr sz="1600" b="0" i="0">
                 <a:solidFill>
                   <a:srgbClr val="1B1B1B"/>
                 </a:solidFill>
@@ -6293,7 +6293,7 @@
           <a:p>
             <a:pPr algn="l"/>
             <a:r>
-              <a:rPr sz="1500" b="0" i="0">
+              <a:rPr sz="1600" b="0" i="0">
                 <a:solidFill>
                   <a:srgbClr val="1B1B1B"/>
                 </a:solidFill>
@@ -6305,7 +6305,7 @@
           <a:p>
             <a:pPr algn="l"/>
             <a:r>
-              <a:rPr sz="1500" b="0" i="0">
+              <a:rPr sz="1600" b="0" i="0">
                 <a:solidFill>
                   <a:srgbClr val="1B1B1B"/>
                 </a:solidFill>
@@ -6317,7 +6317,7 @@
           <a:p>
             <a:pPr algn="l"/>
             <a:r>
-              <a:rPr sz="1500" b="0" i="0">
+              <a:rPr sz="1600" b="0" i="0">
                 <a:solidFill>
                   <a:srgbClr val="1B1B1B"/>
                 </a:solidFill>
@@ -6329,7 +6329,7 @@
           <a:p>
             <a:pPr algn="l"/>
             <a:r>
-              <a:rPr sz="1500" b="0" i="0">
+              <a:rPr sz="1600" b="0" i="0">
                 <a:solidFill>
                   <a:srgbClr val="1B1B1B"/>
                 </a:solidFill>
@@ -6341,7 +6341,7 @@
           <a:p>
             <a:pPr algn="l"/>
             <a:r>
-              <a:rPr sz="1500" b="0" i="0">
+              <a:rPr sz="1600" b="0" i="0">
                 <a:solidFill>
                   <a:srgbClr val="1B1B1B"/>
                 </a:solidFill>
@@ -6353,7 +6353,7 @@
           <a:p>
             <a:pPr algn="l"/>
             <a:r>
-              <a:rPr sz="1500" b="0" i="0">
+              <a:rPr sz="1600" b="0" i="0">
                 <a:solidFill>
                   <a:srgbClr val="1B1B1B"/>
                 </a:solidFill>
@@ -6365,7 +6365,7 @@
           <a:p>
             <a:pPr algn="l"/>
             <a:r>
-              <a:rPr sz="1500" b="0" i="0">
+              <a:rPr sz="1600" b="0" i="0">
                 <a:solidFill>
                   <a:srgbClr val="1B1B1B"/>
                 </a:solidFill>
@@ -6378,42 +6378,7 @@
       </p:sp>
       <p:sp>
         <p:nvSpPr>
-          <p:cNvPr id="11" name="TextBox 10"/>
-          <p:cNvSpPr txBox="1"/>
-          <p:nvPr/>
-        </p:nvSpPr>
-        <p:spPr>
-          <a:xfrm>
-            <a:off x="640080" y="5541264"/>
-            <a:ext cx="10881360" cy="457200"/>
-          </a:xfrm>
-          <a:prstGeom prst="rect">
-            <a:avLst/>
-          </a:prstGeom>
-          <a:noFill/>
-        </p:spPr>
-        <p:txBody>
-          <a:bodyPr wrap="square" anchor="t">
-            <a:noAutofit/>
-          </a:bodyPr>
-          <a:lstStyle/>
-          <a:p>
-            <a:pPr algn="l"/>
-            <a:r>
-              <a:rPr sz="1400" b="1" i="1">
-                <a:solidFill>
-                  <a:srgbClr val="256E8E"/>
-                </a:solidFill>
-                <a:latin typeface="Arial"/>
-              </a:rPr>
-              <a:t>Ask the room:   What's missing? What would you challenge?</a:t>
-            </a:r>
-          </a:p>
-        </p:txBody>
-      </p:sp>
-      <p:sp>
-        <p:nvSpPr>
-          <p:cNvPr id="12" name="Rectangle 11"/>
+          <p:cNvPr id="11" name="Rectangle 10"/>
           <p:cNvSpPr/>
           <p:nvPr/>
         </p:nvSpPr>
@@ -6457,47 +6422,47 @@
       </p:sp>
       <p:sp>
         <p:nvSpPr>
+          <p:cNvPr id="12" name="TextBox 11"/>
+          <p:cNvSpPr txBox="1"/>
+          <p:nvPr/>
+        </p:nvSpPr>
+        <p:spPr>
+          <a:xfrm>
+            <a:off x="640080" y="6473952"/>
+            <a:ext cx="6400800" cy="274320"/>
+          </a:xfrm>
+          <a:prstGeom prst="rect">
+            <a:avLst/>
+          </a:prstGeom>
+          <a:noFill/>
+        </p:spPr>
+        <p:txBody>
+          <a:bodyPr wrap="square" anchor="t">
+            <a:noAutofit/>
+          </a:bodyPr>
+          <a:lstStyle/>
+          <a:p>
+            <a:pPr algn="l"/>
+            <a:r>
+              <a:rPr sz="900" b="0" i="0">
+                <a:solidFill>
+                  <a:srgbClr val="595959"/>
+                </a:solidFill>
+                <a:latin typeface="Arial"/>
+              </a:rPr>
+              <a:t>Industrial DevOps Now  ·  AI-Powered Product Development</a:t>
+            </a:r>
+          </a:p>
+        </p:txBody>
+      </p:sp>
+      <p:sp>
+        <p:nvSpPr>
           <p:cNvPr id="13" name="TextBox 12"/>
           <p:cNvSpPr txBox="1"/>
           <p:nvPr/>
         </p:nvSpPr>
         <p:spPr>
           <a:xfrm>
-            <a:off x="640080" y="6473952"/>
-            <a:ext cx="6400800" cy="274320"/>
-          </a:xfrm>
-          <a:prstGeom prst="rect">
-            <a:avLst/>
-          </a:prstGeom>
-          <a:noFill/>
-        </p:spPr>
-        <p:txBody>
-          <a:bodyPr wrap="square" anchor="t">
-            <a:noAutofit/>
-          </a:bodyPr>
-          <a:lstStyle/>
-          <a:p>
-            <a:pPr algn="l"/>
-            <a:r>
-              <a:rPr sz="900" b="0" i="0">
-                <a:solidFill>
-                  <a:srgbClr val="595959"/>
-                </a:solidFill>
-                <a:latin typeface="Arial"/>
-              </a:rPr>
-              <a:t>Industrial DevOps Now  ·  AI-Powered Product Development</a:t>
-            </a:r>
-          </a:p>
-        </p:txBody>
-      </p:sp>
-      <p:sp>
-        <p:nvSpPr>
-          <p:cNvPr id="14" name="TextBox 13"/>
-          <p:cNvSpPr txBox="1"/>
-          <p:nvPr/>
-        </p:nvSpPr>
-        <p:spPr>
-          <a:xfrm>
             <a:off x="4389120" y="6473952"/>
             <a:ext cx="3657600" cy="274320"/>
           </a:xfrm>
@@ -6527,7 +6492,7 @@
       </p:sp>
       <p:sp>
         <p:nvSpPr>
-          <p:cNvPr id="15" name="TextBox 14"/>
+          <p:cNvPr id="14" name="TextBox 13"/>
           <p:cNvSpPr txBox="1"/>
           <p:nvPr/>
         </p:nvSpPr>
@@ -6800,7 +6765,7 @@
         <p:spPr>
           <a:xfrm>
             <a:off x="640080" y="1901952"/>
-            <a:ext cx="10881360" cy="3520440"/>
+            <a:ext cx="10881360" cy="4114800"/>
           </a:xfrm>
           <a:prstGeom prst="roundRect">
             <a:avLst/>
@@ -6925,7 +6890,7 @@
         <p:spPr>
           <a:xfrm>
             <a:off x="896112" y="2523744"/>
-            <a:ext cx="10369296" cy="2743200"/>
+            <a:ext cx="10369296" cy="3337560"/>
           </a:xfrm>
           <a:prstGeom prst="rect">
             <a:avLst/>
@@ -6940,7 +6905,7 @@
           <a:p>
             <a:pPr algn="l"/>
             <a:r>
-              <a:rPr sz="1500" b="0" i="0">
+              <a:rPr sz="1600" b="0" i="0">
                 <a:solidFill>
                   <a:srgbClr val="1B1B1B"/>
                 </a:solidFill>
@@ -6952,7 +6917,7 @@
           <a:p>
             <a:pPr algn="l"/>
             <a:r>
-              <a:rPr sz="1500" b="0" i="0">
+              <a:rPr sz="1600" b="0" i="0">
                 <a:solidFill>
                   <a:srgbClr val="1B1B1B"/>
                 </a:solidFill>
@@ -6964,7 +6929,7 @@
           <a:p>
             <a:pPr algn="l"/>
             <a:r>
-              <a:rPr sz="1500" b="0" i="0">
+              <a:rPr sz="1600" b="0" i="0">
                 <a:solidFill>
                   <a:srgbClr val="1B1B1B"/>
                 </a:solidFill>
@@ -6976,7 +6941,7 @@
           <a:p>
             <a:pPr algn="l"/>
             <a:r>
-              <a:rPr sz="1500" b="0" i="0">
+              <a:rPr sz="1600" b="0" i="0">
                 <a:solidFill>
                   <a:srgbClr val="1B1B1B"/>
                 </a:solidFill>
@@ -6988,7 +6953,7 @@
           <a:p>
             <a:pPr algn="l"/>
             <a:r>
-              <a:rPr sz="1500" b="0" i="0">
+              <a:rPr sz="1600" b="0" i="0">
                 <a:solidFill>
                   <a:srgbClr val="1B1B1B"/>
                 </a:solidFill>
@@ -7000,7 +6965,7 @@
           <a:p>
             <a:pPr algn="l"/>
             <a:r>
-              <a:rPr sz="1500" b="0" i="0">
+              <a:rPr sz="1600" b="0" i="0">
                 <a:solidFill>
                   <a:srgbClr val="1B1B1B"/>
                 </a:solidFill>
@@ -7012,7 +6977,7 @@
           <a:p>
             <a:pPr algn="l"/>
             <a:r>
-              <a:rPr sz="1500" b="0" i="0">
+              <a:rPr sz="1600" b="0" i="0">
                 <a:solidFill>
                   <a:srgbClr val="1B1B1B"/>
                 </a:solidFill>
@@ -7024,7 +6989,7 @@
           <a:p>
             <a:pPr algn="l"/>
             <a:r>
-              <a:rPr sz="1500" b="0" i="0">
+              <a:rPr sz="1600" b="0" i="0">
                 <a:solidFill>
                   <a:srgbClr val="1B1B1B"/>
                 </a:solidFill>
@@ -7037,42 +7002,7 @@
       </p:sp>
       <p:sp>
         <p:nvSpPr>
-          <p:cNvPr id="11" name="TextBox 10"/>
-          <p:cNvSpPr txBox="1"/>
-          <p:nvPr/>
-        </p:nvSpPr>
-        <p:spPr>
-          <a:xfrm>
-            <a:off x="640080" y="5541264"/>
-            <a:ext cx="10881360" cy="457200"/>
-          </a:xfrm>
-          <a:prstGeom prst="rect">
-            <a:avLst/>
-          </a:prstGeom>
-          <a:noFill/>
-        </p:spPr>
-        <p:txBody>
-          <a:bodyPr wrap="square" anchor="t">
-            <a:noAutofit/>
-          </a:bodyPr>
-          <a:lstStyle/>
-          <a:p>
-            <a:pPr algn="l"/>
-            <a:r>
-              <a:rPr sz="1400" b="1" i="1">
-                <a:solidFill>
-                  <a:srgbClr val="256E8E"/>
-                </a:solidFill>
-                <a:latin typeface="Arial"/>
-              </a:rPr>
-              <a:t>Ask the room:   Where could this go wrong, and how does it stay safe?</a:t>
-            </a:r>
-          </a:p>
-        </p:txBody>
-      </p:sp>
-      <p:sp>
-        <p:nvSpPr>
-          <p:cNvPr id="12" name="Rectangle 11"/>
+          <p:cNvPr id="11" name="Rectangle 10"/>
           <p:cNvSpPr/>
           <p:nvPr/>
         </p:nvSpPr>
@@ -7116,47 +7046,47 @@
       </p:sp>
       <p:sp>
         <p:nvSpPr>
+          <p:cNvPr id="12" name="TextBox 11"/>
+          <p:cNvSpPr txBox="1"/>
+          <p:nvPr/>
+        </p:nvSpPr>
+        <p:spPr>
+          <a:xfrm>
+            <a:off x="640080" y="6473952"/>
+            <a:ext cx="6400800" cy="274320"/>
+          </a:xfrm>
+          <a:prstGeom prst="rect">
+            <a:avLst/>
+          </a:prstGeom>
+          <a:noFill/>
+        </p:spPr>
+        <p:txBody>
+          <a:bodyPr wrap="square" anchor="t">
+            <a:noAutofit/>
+          </a:bodyPr>
+          <a:lstStyle/>
+          <a:p>
+            <a:pPr algn="l"/>
+            <a:r>
+              <a:rPr sz="900" b="0" i="0">
+                <a:solidFill>
+                  <a:srgbClr val="595959"/>
+                </a:solidFill>
+                <a:latin typeface="Arial"/>
+              </a:rPr>
+              <a:t>Industrial DevOps Now  ·  AI-Powered Product Development</a:t>
+            </a:r>
+          </a:p>
+        </p:txBody>
+      </p:sp>
+      <p:sp>
+        <p:nvSpPr>
           <p:cNvPr id="13" name="TextBox 12"/>
           <p:cNvSpPr txBox="1"/>
           <p:nvPr/>
         </p:nvSpPr>
         <p:spPr>
           <a:xfrm>
-            <a:off x="640080" y="6473952"/>
-            <a:ext cx="6400800" cy="274320"/>
-          </a:xfrm>
-          <a:prstGeom prst="rect">
-            <a:avLst/>
-          </a:prstGeom>
-          <a:noFill/>
-        </p:spPr>
-        <p:txBody>
-          <a:bodyPr wrap="square" anchor="t">
-            <a:noAutofit/>
-          </a:bodyPr>
-          <a:lstStyle/>
-          <a:p>
-            <a:pPr algn="l"/>
-            <a:r>
-              <a:rPr sz="900" b="0" i="0">
-                <a:solidFill>
-                  <a:srgbClr val="595959"/>
-                </a:solidFill>
-                <a:latin typeface="Arial"/>
-              </a:rPr>
-              <a:t>Industrial DevOps Now  ·  AI-Powered Product Development</a:t>
-            </a:r>
-          </a:p>
-        </p:txBody>
-      </p:sp>
-      <p:sp>
-        <p:nvSpPr>
-          <p:cNvPr id="14" name="TextBox 13"/>
-          <p:cNvSpPr txBox="1"/>
-          <p:nvPr/>
-        </p:nvSpPr>
-        <p:spPr>
-          <a:xfrm>
             <a:off x="4389120" y="6473952"/>
             <a:ext cx="3657600" cy="274320"/>
           </a:xfrm>
@@ -7186,7 +7116,7 @@
       </p:sp>
       <p:sp>
         <p:nvSpPr>
-          <p:cNvPr id="15" name="TextBox 14"/>
+          <p:cNvPr id="14" name="TextBox 13"/>
           <p:cNvSpPr txBox="1"/>
           <p:nvPr/>
         </p:nvSpPr>
@@ -7459,7 +7389,7 @@
         <p:spPr>
           <a:xfrm>
             <a:off x="640080" y="1901952"/>
-            <a:ext cx="10881360" cy="3520440"/>
+            <a:ext cx="10881360" cy="4114800"/>
           </a:xfrm>
           <a:prstGeom prst="roundRect">
             <a:avLst/>
@@ -7584,7 +7514,7 @@
         <p:spPr>
           <a:xfrm>
             <a:off x="896112" y="2523744"/>
-            <a:ext cx="10369296" cy="2743200"/>
+            <a:ext cx="10369296" cy="3337560"/>
           </a:xfrm>
           <a:prstGeom prst="rect">
             <a:avLst/>
@@ -7599,7 +7529,7 @@
           <a:p>
             <a:pPr algn="l"/>
             <a:r>
-              <a:rPr sz="1500" b="0" i="0">
+              <a:rPr sz="1600" b="0" i="0">
                 <a:solidFill>
                   <a:srgbClr val="1B1B1B"/>
                 </a:solidFill>
@@ -7611,7 +7541,7 @@
           <a:p>
             <a:pPr algn="l"/>
             <a:r>
-              <a:rPr sz="1500" b="0" i="0">
+              <a:rPr sz="1600" b="0" i="0">
                 <a:solidFill>
                   <a:srgbClr val="1B1B1B"/>
                 </a:solidFill>
@@ -7623,7 +7553,7 @@
           <a:p>
             <a:pPr algn="l"/>
             <a:r>
-              <a:rPr sz="1500" b="0" i="0">
+              <a:rPr sz="1600" b="0" i="0">
                 <a:solidFill>
                   <a:srgbClr val="1B1B1B"/>
                 </a:solidFill>
@@ -7635,7 +7565,7 @@
           <a:p>
             <a:pPr algn="l"/>
             <a:r>
-              <a:rPr sz="1500" b="0" i="0">
+              <a:rPr sz="1600" b="0" i="0">
                 <a:solidFill>
                   <a:srgbClr val="1B1B1B"/>
                 </a:solidFill>
@@ -7647,7 +7577,7 @@
           <a:p>
             <a:pPr algn="l"/>
             <a:r>
-              <a:rPr sz="1500" b="0" i="0">
+              <a:rPr sz="1600" b="0" i="0">
                 <a:solidFill>
                   <a:srgbClr val="1B1B1B"/>
                 </a:solidFill>
@@ -7659,7 +7589,7 @@
           <a:p>
             <a:pPr algn="l"/>
             <a:r>
-              <a:rPr sz="1500" b="0" i="0">
+              <a:rPr sz="1600" b="0" i="0">
                 <a:solidFill>
                   <a:srgbClr val="1B1B1B"/>
                 </a:solidFill>
@@ -7671,7 +7601,7 @@
           <a:p>
             <a:pPr algn="l"/>
             <a:r>
-              <a:rPr sz="1500" b="0" i="0">
+              <a:rPr sz="1600" b="0" i="0">
                 <a:solidFill>
                   <a:srgbClr val="1B1B1B"/>
                 </a:solidFill>
@@ -7683,7 +7613,7 @@
           <a:p>
             <a:pPr algn="l"/>
             <a:r>
-              <a:rPr sz="1500" b="0" i="0">
+              <a:rPr sz="1600" b="0" i="0">
                 <a:solidFill>
                   <a:srgbClr val="1B1B1B"/>
                 </a:solidFill>
@@ -7696,42 +7626,7 @@
       </p:sp>
       <p:sp>
         <p:nvSpPr>
-          <p:cNvPr id="11" name="TextBox 10"/>
-          <p:cNvSpPr txBox="1"/>
-          <p:nvPr/>
-        </p:nvSpPr>
-        <p:spPr>
-          <a:xfrm>
-            <a:off x="640080" y="5541264"/>
-            <a:ext cx="10881360" cy="457200"/>
-          </a:xfrm>
-          <a:prstGeom prst="rect">
-            <a:avLst/>
-          </a:prstGeom>
-          <a:noFill/>
-        </p:spPr>
-        <p:txBody>
-          <a:bodyPr wrap="square" anchor="t">
-            <a:noAutofit/>
-          </a:bodyPr>
-          <a:lstStyle/>
-          <a:p>
-            <a:pPr algn="l"/>
-            <a:r>
-              <a:rPr sz="1400" b="1" i="1">
-                <a:solidFill>
-                  <a:srgbClr val="256E8E"/>
-                </a:solidFill>
-                <a:latin typeface="Arial"/>
-              </a:rPr>
-              <a:t>Ask the room:   See how it traces back to the requirements.</a:t>
-            </a:r>
-          </a:p>
-        </p:txBody>
-      </p:sp>
-      <p:sp>
-        <p:nvSpPr>
-          <p:cNvPr id="12" name="Rectangle 11"/>
+          <p:cNvPr id="11" name="Rectangle 10"/>
           <p:cNvSpPr/>
           <p:nvPr/>
         </p:nvSpPr>
@@ -7775,47 +7670,47 @@
       </p:sp>
       <p:sp>
         <p:nvSpPr>
+          <p:cNvPr id="12" name="TextBox 11"/>
+          <p:cNvSpPr txBox="1"/>
+          <p:nvPr/>
+        </p:nvSpPr>
+        <p:spPr>
+          <a:xfrm>
+            <a:off x="640080" y="6473952"/>
+            <a:ext cx="6400800" cy="274320"/>
+          </a:xfrm>
+          <a:prstGeom prst="rect">
+            <a:avLst/>
+          </a:prstGeom>
+          <a:noFill/>
+        </p:spPr>
+        <p:txBody>
+          <a:bodyPr wrap="square" anchor="t">
+            <a:noAutofit/>
+          </a:bodyPr>
+          <a:lstStyle/>
+          <a:p>
+            <a:pPr algn="l"/>
+            <a:r>
+              <a:rPr sz="900" b="0" i="0">
+                <a:solidFill>
+                  <a:srgbClr val="595959"/>
+                </a:solidFill>
+                <a:latin typeface="Arial"/>
+              </a:rPr>
+              <a:t>Industrial DevOps Now  ·  AI-Powered Product Development</a:t>
+            </a:r>
+          </a:p>
+        </p:txBody>
+      </p:sp>
+      <p:sp>
+        <p:nvSpPr>
           <p:cNvPr id="13" name="TextBox 12"/>
           <p:cNvSpPr txBox="1"/>
           <p:nvPr/>
         </p:nvSpPr>
         <p:spPr>
           <a:xfrm>
-            <a:off x="640080" y="6473952"/>
-            <a:ext cx="6400800" cy="274320"/>
-          </a:xfrm>
-          <a:prstGeom prst="rect">
-            <a:avLst/>
-          </a:prstGeom>
-          <a:noFill/>
-        </p:spPr>
-        <p:txBody>
-          <a:bodyPr wrap="square" anchor="t">
-            <a:noAutofit/>
-          </a:bodyPr>
-          <a:lstStyle/>
-          <a:p>
-            <a:pPr algn="l"/>
-            <a:r>
-              <a:rPr sz="900" b="0" i="0">
-                <a:solidFill>
-                  <a:srgbClr val="595959"/>
-                </a:solidFill>
-                <a:latin typeface="Arial"/>
-              </a:rPr>
-              <a:t>Industrial DevOps Now  ·  AI-Powered Product Development</a:t>
-            </a:r>
-          </a:p>
-        </p:txBody>
-      </p:sp>
-      <p:sp>
-        <p:nvSpPr>
-          <p:cNvPr id="14" name="TextBox 13"/>
-          <p:cNvSpPr txBox="1"/>
-          <p:nvPr/>
-        </p:nvSpPr>
-        <p:spPr>
-          <a:xfrm>
             <a:off x="4389120" y="6473952"/>
             <a:ext cx="3657600" cy="274320"/>
           </a:xfrm>
@@ -7845,7 +7740,7 @@
       </p:sp>
       <p:sp>
         <p:nvSpPr>
-          <p:cNvPr id="15" name="TextBox 14"/>
+          <p:cNvPr id="14" name="TextBox 13"/>
           <p:cNvSpPr txBox="1"/>
           <p:nvPr/>
         </p:nvSpPr>
@@ -8118,7 +8013,7 @@
         <p:spPr>
           <a:xfrm>
             <a:off x="640080" y="1901952"/>
-            <a:ext cx="10881360" cy="3520440"/>
+            <a:ext cx="10881360" cy="4114800"/>
           </a:xfrm>
           <a:prstGeom prst="roundRect">
             <a:avLst/>
@@ -8243,7 +8138,7 @@
         <p:spPr>
           <a:xfrm>
             <a:off x="896112" y="2523744"/>
-            <a:ext cx="10369296" cy="2743200"/>
+            <a:ext cx="10369296" cy="3337560"/>
           </a:xfrm>
           <a:prstGeom prst="rect">
             <a:avLst/>
@@ -8258,7 +8153,7 @@
           <a:p>
             <a:pPr algn="l"/>
             <a:r>
-              <a:rPr sz="1500" b="0" i="0">
+              <a:rPr sz="1600" b="0" i="0">
                 <a:solidFill>
                   <a:srgbClr val="1B1B1B"/>
                 </a:solidFill>
@@ -8270,7 +8165,7 @@
           <a:p>
             <a:pPr algn="l"/>
             <a:r>
-              <a:rPr sz="1500" b="0" i="0">
+              <a:rPr sz="1600" b="0" i="0">
                 <a:solidFill>
                   <a:srgbClr val="1B1B1B"/>
                 </a:solidFill>
@@ -8282,7 +8177,7 @@
           <a:p>
             <a:pPr algn="l"/>
             <a:r>
-              <a:rPr sz="1500" b="0" i="0">
+              <a:rPr sz="1600" b="0" i="0">
                 <a:solidFill>
                   <a:srgbClr val="1B1B1B"/>
                 </a:solidFill>
@@ -8294,7 +8189,7 @@
           <a:p>
             <a:pPr algn="l"/>
             <a:r>
-              <a:rPr sz="1500" b="0" i="0">
+              <a:rPr sz="1600" b="0" i="0">
                 <a:solidFill>
                   <a:srgbClr val="1B1B1B"/>
                 </a:solidFill>
@@ -8306,7 +8201,7 @@
           <a:p>
             <a:pPr algn="l"/>
             <a:r>
-              <a:rPr sz="1500" b="0" i="0">
+              <a:rPr sz="1600" b="0" i="0">
                 <a:solidFill>
                   <a:srgbClr val="1B1B1B"/>
                 </a:solidFill>
@@ -8318,7 +8213,7 @@
           <a:p>
             <a:pPr algn="l"/>
             <a:r>
-              <a:rPr sz="1500" b="0" i="0">
+              <a:rPr sz="1600" b="0" i="0">
                 <a:solidFill>
                   <a:srgbClr val="1B1B1B"/>
                 </a:solidFill>
@@ -8330,7 +8225,7 @@
           <a:p>
             <a:pPr algn="l"/>
             <a:r>
-              <a:rPr sz="1500" b="0" i="0">
+              <a:rPr sz="1600" b="0" i="0">
                 <a:solidFill>
                   <a:srgbClr val="1B1B1B"/>
                 </a:solidFill>
@@ -8342,7 +8237,7 @@
           <a:p>
             <a:pPr algn="l"/>
             <a:r>
-              <a:rPr sz="1500" b="0" i="0">
+              <a:rPr sz="1600" b="0" i="0">
                 <a:solidFill>
                   <a:srgbClr val="1B1B1B"/>
                 </a:solidFill>
@@ -8354,7 +8249,7 @@
           <a:p>
             <a:pPr algn="l"/>
             <a:r>
-              <a:rPr sz="1500" b="0" i="0">
+              <a:rPr sz="1600" b="0" i="0">
                 <a:solidFill>
                   <a:srgbClr val="1B1B1B"/>
                 </a:solidFill>
@@ -8367,42 +8262,7 @@
       </p:sp>
       <p:sp>
         <p:nvSpPr>
-          <p:cNvPr id="11" name="TextBox 10"/>
-          <p:cNvSpPr txBox="1"/>
-          <p:nvPr/>
-        </p:nvSpPr>
-        <p:spPr>
-          <a:xfrm>
-            <a:off x="640080" y="5541264"/>
-            <a:ext cx="10881360" cy="457200"/>
-          </a:xfrm>
-          <a:prstGeom prst="rect">
-            <a:avLst/>
-          </a:prstGeom>
-          <a:noFill/>
-        </p:spPr>
-        <p:txBody>
-          <a:bodyPr wrap="square" anchor="t">
-            <a:noAutofit/>
-          </a:bodyPr>
-          <a:lstStyle/>
-          <a:p>
-            <a:pPr algn="l"/>
-            <a:r>
-              <a:rPr sz="1400" b="1" i="1">
-                <a:solidFill>
-                  <a:srgbClr val="256E8E"/>
-                </a:solidFill>
-                <a:latin typeface="Arial"/>
-              </a:rPr>
-              <a:t>Ask the room:   Which test would you most want to pass before shipping?</a:t>
-            </a:r>
-          </a:p>
-        </p:txBody>
-      </p:sp>
-      <p:sp>
-        <p:nvSpPr>
-          <p:cNvPr id="12" name="Rectangle 11"/>
+          <p:cNvPr id="11" name="Rectangle 10"/>
           <p:cNvSpPr/>
           <p:nvPr/>
         </p:nvSpPr>
@@ -8446,47 +8306,47 @@
       </p:sp>
       <p:sp>
         <p:nvSpPr>
+          <p:cNvPr id="12" name="TextBox 11"/>
+          <p:cNvSpPr txBox="1"/>
+          <p:nvPr/>
+        </p:nvSpPr>
+        <p:spPr>
+          <a:xfrm>
+            <a:off x="640080" y="6473952"/>
+            <a:ext cx="6400800" cy="274320"/>
+          </a:xfrm>
+          <a:prstGeom prst="rect">
+            <a:avLst/>
+          </a:prstGeom>
+          <a:noFill/>
+        </p:spPr>
+        <p:txBody>
+          <a:bodyPr wrap="square" anchor="t">
+            <a:noAutofit/>
+          </a:bodyPr>
+          <a:lstStyle/>
+          <a:p>
+            <a:pPr algn="l"/>
+            <a:r>
+              <a:rPr sz="900" b="0" i="0">
+                <a:solidFill>
+                  <a:srgbClr val="595959"/>
+                </a:solidFill>
+                <a:latin typeface="Arial"/>
+              </a:rPr>
+              <a:t>Industrial DevOps Now  ·  AI-Powered Product Development</a:t>
+            </a:r>
+          </a:p>
+        </p:txBody>
+      </p:sp>
+      <p:sp>
+        <p:nvSpPr>
           <p:cNvPr id="13" name="TextBox 12"/>
           <p:cNvSpPr txBox="1"/>
           <p:nvPr/>
         </p:nvSpPr>
         <p:spPr>
           <a:xfrm>
-            <a:off x="640080" y="6473952"/>
-            <a:ext cx="6400800" cy="274320"/>
-          </a:xfrm>
-          <a:prstGeom prst="rect">
-            <a:avLst/>
-          </a:prstGeom>
-          <a:noFill/>
-        </p:spPr>
-        <p:txBody>
-          <a:bodyPr wrap="square" anchor="t">
-            <a:noAutofit/>
-          </a:bodyPr>
-          <a:lstStyle/>
-          <a:p>
-            <a:pPr algn="l"/>
-            <a:r>
-              <a:rPr sz="900" b="0" i="0">
-                <a:solidFill>
-                  <a:srgbClr val="595959"/>
-                </a:solidFill>
-                <a:latin typeface="Arial"/>
-              </a:rPr>
-              <a:t>Industrial DevOps Now  ·  AI-Powered Product Development</a:t>
-            </a:r>
-          </a:p>
-        </p:txBody>
-      </p:sp>
-      <p:sp>
-        <p:nvSpPr>
-          <p:cNvPr id="14" name="TextBox 13"/>
-          <p:cNvSpPr txBox="1"/>
-          <p:nvPr/>
-        </p:nvSpPr>
-        <p:spPr>
-          <a:xfrm>
             <a:off x="4389120" y="6473952"/>
             <a:ext cx="3657600" cy="274320"/>
           </a:xfrm>
@@ -8516,7 +8376,7 @@
       </p:sp>
       <p:sp>
         <p:nvSpPr>
-          <p:cNvPr id="15" name="TextBox 14"/>
+          <p:cNvPr id="14" name="TextBox 13"/>
           <p:cNvSpPr txBox="1"/>
           <p:nvPr/>
         </p:nvSpPr>
@@ -10188,7 +10048,7 @@
         <p:spPr>
           <a:xfrm>
             <a:off x="640080" y="1901952"/>
-            <a:ext cx="10881360" cy="3520440"/>
+            <a:ext cx="10881360" cy="4114800"/>
           </a:xfrm>
           <a:prstGeom prst="roundRect">
             <a:avLst/>
@@ -10313,7 +10173,7 @@
         <p:spPr>
           <a:xfrm>
             <a:off x="896112" y="2523744"/>
-            <a:ext cx="10369296" cy="2743200"/>
+            <a:ext cx="10369296" cy="3337560"/>
           </a:xfrm>
           <a:prstGeom prst="rect">
             <a:avLst/>
@@ -10328,7 +10188,7 @@
           <a:p>
             <a:pPr algn="l"/>
             <a:r>
-              <a:rPr sz="1500" b="0" i="0">
+              <a:rPr sz="1600" b="0" i="0">
                 <a:solidFill>
                   <a:srgbClr val="1B1B1B"/>
                 </a:solidFill>
@@ -10340,7 +10200,7 @@
           <a:p>
             <a:pPr algn="l"/>
             <a:r>
-              <a:rPr sz="1500" b="0" i="0">
+              <a:rPr sz="1600" b="0" i="0">
                 <a:solidFill>
                   <a:srgbClr val="1B1B1B"/>
                 </a:solidFill>
@@ -10352,7 +10212,7 @@
           <a:p>
             <a:pPr algn="l"/>
             <a:r>
-              <a:rPr sz="1500" b="0" i="0">
+              <a:rPr sz="1600" b="0" i="0">
                 <a:solidFill>
                   <a:srgbClr val="1B1B1B"/>
                 </a:solidFill>
@@ -10364,7 +10224,7 @@
           <a:p>
             <a:pPr algn="l"/>
             <a:r>
-              <a:rPr sz="1500" b="0" i="0">
+              <a:rPr sz="1600" b="0" i="0">
                 <a:solidFill>
                   <a:srgbClr val="1B1B1B"/>
                 </a:solidFill>
@@ -10376,7 +10236,7 @@
           <a:p>
             <a:pPr algn="l"/>
             <a:r>
-              <a:rPr sz="1500" b="0" i="0">
+              <a:rPr sz="1600" b="0" i="0">
                 <a:solidFill>
                   <a:srgbClr val="1B1B1B"/>
                 </a:solidFill>
@@ -10388,7 +10248,7 @@
           <a:p>
             <a:pPr algn="l"/>
             <a:r>
-              <a:rPr sz="1500" b="0" i="0">
+              <a:rPr sz="1600" b="0" i="0">
                 <a:solidFill>
                   <a:srgbClr val="1B1B1B"/>
                 </a:solidFill>
@@ -10400,7 +10260,7 @@
           <a:p>
             <a:pPr algn="l"/>
             <a:r>
-              <a:rPr sz="1500" b="0" i="0">
+              <a:rPr sz="1600" b="0" i="0">
                 <a:solidFill>
                   <a:srgbClr val="1B1B1B"/>
                 </a:solidFill>
@@ -10412,7 +10272,7 @@
           <a:p>
             <a:pPr algn="l"/>
             <a:r>
-              <a:rPr sz="1500" b="0" i="0">
+              <a:rPr sz="1600" b="0" i="0">
                 <a:solidFill>
                   <a:srgbClr val="1B1B1B"/>
                 </a:solidFill>
@@ -10425,42 +10285,7 @@
       </p:sp>
       <p:sp>
         <p:nvSpPr>
-          <p:cNvPr id="11" name="TextBox 10"/>
-          <p:cNvSpPr txBox="1"/>
-          <p:nvPr/>
-        </p:nvSpPr>
-        <p:spPr>
-          <a:xfrm>
-            <a:off x="640080" y="5541264"/>
-            <a:ext cx="10881360" cy="457200"/>
-          </a:xfrm>
-          <a:prstGeom prst="rect">
-            <a:avLst/>
-          </a:prstGeom>
-          <a:noFill/>
-        </p:spPr>
-        <p:txBody>
-          <a:bodyPr wrap="square" anchor="t">
-            <a:noAutofit/>
-          </a:bodyPr>
-          <a:lstStyle/>
-          <a:p>
-            <a:pPr algn="l"/>
-            <a:r>
-              <a:rPr sz="1400" b="1" i="1">
-                <a:solidFill>
-                  <a:srgbClr val="256E8E"/>
-                </a:solidFill>
-                <a:latin typeface="Arial"/>
-              </a:rPr>
-              <a:t>Ask the room:   How many teams would this normally take?</a:t>
-            </a:r>
-          </a:p>
-        </p:txBody>
-      </p:sp>
-      <p:sp>
-        <p:nvSpPr>
-          <p:cNvPr id="12" name="Rectangle 11"/>
+          <p:cNvPr id="11" name="Rectangle 10"/>
           <p:cNvSpPr/>
           <p:nvPr/>
         </p:nvSpPr>
@@ -10504,47 +10329,47 @@
       </p:sp>
       <p:sp>
         <p:nvSpPr>
+          <p:cNvPr id="12" name="TextBox 11"/>
+          <p:cNvSpPr txBox="1"/>
+          <p:nvPr/>
+        </p:nvSpPr>
+        <p:spPr>
+          <a:xfrm>
+            <a:off x="640080" y="6473952"/>
+            <a:ext cx="6400800" cy="274320"/>
+          </a:xfrm>
+          <a:prstGeom prst="rect">
+            <a:avLst/>
+          </a:prstGeom>
+          <a:noFill/>
+        </p:spPr>
+        <p:txBody>
+          <a:bodyPr wrap="square" anchor="t">
+            <a:noAutofit/>
+          </a:bodyPr>
+          <a:lstStyle/>
+          <a:p>
+            <a:pPr algn="l"/>
+            <a:r>
+              <a:rPr sz="900" b="0" i="0">
+                <a:solidFill>
+                  <a:srgbClr val="595959"/>
+                </a:solidFill>
+                <a:latin typeface="Arial"/>
+              </a:rPr>
+              <a:t>Industrial DevOps Now  ·  AI-Powered Product Development</a:t>
+            </a:r>
+          </a:p>
+        </p:txBody>
+      </p:sp>
+      <p:sp>
+        <p:nvSpPr>
           <p:cNvPr id="13" name="TextBox 12"/>
           <p:cNvSpPr txBox="1"/>
           <p:nvPr/>
         </p:nvSpPr>
         <p:spPr>
           <a:xfrm>
-            <a:off x="640080" y="6473952"/>
-            <a:ext cx="6400800" cy="274320"/>
-          </a:xfrm>
-          <a:prstGeom prst="rect">
-            <a:avLst/>
-          </a:prstGeom>
-          <a:noFill/>
-        </p:spPr>
-        <p:txBody>
-          <a:bodyPr wrap="square" anchor="t">
-            <a:noAutofit/>
-          </a:bodyPr>
-          <a:lstStyle/>
-          <a:p>
-            <a:pPr algn="l"/>
-            <a:r>
-              <a:rPr sz="900" b="0" i="0">
-                <a:solidFill>
-                  <a:srgbClr val="595959"/>
-                </a:solidFill>
-                <a:latin typeface="Arial"/>
-              </a:rPr>
-              <a:t>Industrial DevOps Now  ·  AI-Powered Product Development</a:t>
-            </a:r>
-          </a:p>
-        </p:txBody>
-      </p:sp>
-      <p:sp>
-        <p:nvSpPr>
-          <p:cNvPr id="14" name="TextBox 13"/>
-          <p:cNvSpPr txBox="1"/>
-          <p:nvPr/>
-        </p:nvSpPr>
-        <p:spPr>
-          <a:xfrm>
             <a:off x="4389120" y="6473952"/>
             <a:ext cx="3657600" cy="274320"/>
           </a:xfrm>
@@ -10574,7 +10399,7 @@
       </p:sp>
       <p:sp>
         <p:nvSpPr>
-          <p:cNvPr id="15" name="TextBox 14"/>
+          <p:cNvPr id="14" name="TextBox 13"/>
           <p:cNvSpPr txBox="1"/>
           <p:nvPr/>
         </p:nvSpPr>

</xml_diff>